<commit_message>
docs: rà soát line-by-line, chuẩn hóa tuyệt đối văn phong học thuật và đồng bộ sản phẩm nộp
</commit_message>
<xml_diff>
--- a/nop/02-slide-mon-hoc.pptx
+++ b/nop/02-slide-mon-hoc.pptx
@@ -44319,7 +44319,7 @@
             <p:ph idx="1"/>
             <p:extLst>
               <p:ext uri="{D42A27DB-BD31-4B8C-83A1-F6EECF244321}">
-                <p14:modId xmlns:p14="http://schemas.microsoft.com/office/powerpoint/2010/main" val="2575042147"/>
+                <p14:modId xmlns:p14="http://schemas.microsoft.com/office/powerpoint/2010/main" val="4240079268"/>
               </p:ext>
             </p:extLst>
           </p:nvPr>
@@ -44988,8 +44988,8 @@
         </p:blipFill>
         <p:spPr bwMode="auto">
           <a:xfrm>
-            <a:off x="1778000" y="2324100"/>
-            <a:ext cx="8547100" cy="3848100"/>
+            <a:off x="1854200" y="2324100"/>
+            <a:ext cx="8394700" cy="3848100"/>
           </a:xfrm>
           <a:prstGeom prst="rect">
             <a:avLst/>
@@ -46173,7 +46173,7 @@
             </a:r>
             <a:r>
               <a:rPr b="1"/>
-              <a:t>cả ba ca sai đều hỏng ở dòng trên</a:t>
+              <a:t>cả ba ca sai đều gặp lỗi ở dòng trên</a:t>
             </a:r>
             <a:r>
               <a:t>.</a:t>
@@ -48055,7 +48055,7 @@
             <p:ph idx="1"/>
             <p:extLst>
               <p:ext uri="{D42A27DB-BD31-4B8C-83A1-F6EECF244321}">
-                <p14:modId xmlns:p14="http://schemas.microsoft.com/office/powerpoint/2010/main" val="1966600073"/>
+                <p14:modId xmlns:p14="http://schemas.microsoft.com/office/powerpoint/2010/main" val="2669706308"/>
               </p:ext>
             </p:extLst>
           </p:nvPr>

</xml_diff>